<commit_message>
Correct evidence integrity, supported XI workloads and grounded agent; add franchise themes
Preserve player identities and raw totals, correct phase filters, enforce complete bowling allocation, isolate private-session records, and gate research forecasts against the learned chase baseline. Add bundled marks, franchise accents and Light/Dark appearance.

Validation: 31 core regressions, 41 UI workflow checks and 5 local Chromium checks. Live provider quality and full current squad verification remain disclosed limits.
</commit_message>
<xml_diff>
--- a/docs/Capstone_Presentation.pptx
+++ b/docs/Capstone_Presentation.pptx
@@ -3093,7 +3093,7 @@
     <p:bg>
       <p:bgPr>
         <a:solidFill>
-          <a:srgbClr val="F6F5F0"/>
+          <a:srgbClr val="101820"/>
         </a:solidFill>
         <a:effectLst/>
       </p:bgPr>
@@ -3113,8 +3113,8 @@
         </p:nvSpPr>
         <p:spPr>
           <a:xfrm>
-            <a:off x="594360" y="411480"/>
-            <a:ext cx="10972800" cy="365760"/>
+            <a:off x="731520" y="457200"/>
+            <a:ext cx="10789920" cy="365760"/>
           </a:xfrm>
           <a:prstGeom prst="rect">
             <a:avLst/>
@@ -3122,15 +3122,18 @@
           <a:noFill/>
         </p:spPr>
         <p:txBody>
-          <a:bodyPr wrap="none">
+          <a:bodyPr wrap="square">
             <a:spAutoFit/>
           </a:bodyPr>
           <a:lstStyle/>
           <a:p>
             <a:pPr>
+              <a:spcAft>
+                <a:spcPts val="2400"/>
+              </a:spcAft>
               <a:defRPr sz="1100">
                 <a:solidFill>
-                  <a:srgbClr val="176B55"/>
+                  <a:srgbClr val="FF8798"/>
                 </a:solidFill>
               </a:defRPr>
             </a:pPr>
@@ -3148,8 +3151,8 @@
         </p:nvSpPr>
         <p:spPr>
           <a:xfrm>
-            <a:off x="594360" y="1143000"/>
-            <a:ext cx="10972800" cy="1005840"/>
+            <a:off x="731520" y="1280160"/>
+            <a:ext cx="10789920" cy="1005840"/>
           </a:xfrm>
           <a:prstGeom prst="rect">
             <a:avLst/>
@@ -3157,17 +3160,19 @@
           <a:noFill/>
         </p:spPr>
         <p:txBody>
-          <a:bodyPr wrap="none">
+          <a:bodyPr wrap="square">
             <a:spAutoFit/>
           </a:bodyPr>
           <a:lstStyle/>
           <a:p>
             <a:pPr>
-              <a:defRPr sz="3700">
-                <a:solidFill>
-                  <a:srgbClr val="182D32"/>
-                </a:solidFill>
-                <a:latin typeface="Georgia"/>
+              <a:spcAft>
+                <a:spcPts val="2400"/>
+              </a:spcAft>
+              <a:defRPr sz="3600">
+                <a:solidFill>
+                  <a:srgbClr val="E8EDF1"/>
+                </a:solidFill>
               </a:defRPr>
             </a:pPr>
             <a:r>
@@ -3184,8 +3189,8 @@
         </p:nvSpPr>
         <p:spPr>
           <a:xfrm>
-            <a:off x="685800" y="2651760"/>
-            <a:ext cx="10698480" cy="3657600"/>
+            <a:off x="731520" y="2743200"/>
+            <a:ext cx="10789920" cy="3657600"/>
           </a:xfrm>
           <a:prstGeom prst="rect">
             <a:avLst/>
@@ -3200,46 +3205,16 @@
           <a:p>
             <a:pPr>
               <a:spcAft>
-                <a:spcPts val="2200"/>
+                <a:spcPts val="2400"/>
               </a:spcAft>
-              <a:defRPr sz="2500">
-                <a:solidFill>
-                  <a:srgbClr val="344D4E"/>
+              <a:defRPr sz="2400">
+                <a:solidFill>
+                  <a:srgbClr val="A8B8C5"/>
                 </a:solidFill>
               </a:defRPr>
             </a:pPr>
             <a:r>
-              <a:t>Franchise research studio</a:t>
-            </a:r>
-          </a:p>
-          <a:p>
-            <a:pPr>
-              <a:spcAft>
-                <a:spcPts val="2200"/>
-              </a:spcAft>
-              <a:defRPr sz="2500">
-                <a:solidFill>
-                  <a:srgbClr val="344D4E"/>
-                </a:solidFill>
-              </a:defRPr>
-            </a:pPr>
-            <a:r>
-              <a:t>One integrated capstone release</a:t>
-            </a:r>
-          </a:p>
-          <a:p>
-            <a:pPr>
-              <a:spcAft>
-                <a:spcPts val="2200"/>
-              </a:spcAft>
-              <a:defRPr sz="2500">
-                <a:solidFill>
-                  <a:srgbClr val="344D4E"/>
-                </a:solidFill>
-              </a:defRPr>
-            </a:pPr>
-            <a:r>
-              <a:t>18 October 2026</a:t>
+              <a:t>Evidence, decisions and an inspectable research trail</a:t>
             </a:r>
           </a:p>
         </p:txBody>
@@ -3258,7 +3233,7 @@
     <p:bg>
       <p:bgPr>
         <a:solidFill>
-          <a:srgbClr val="F6F5F0"/>
+          <a:srgbClr val="101820"/>
         </a:solidFill>
         <a:effectLst/>
       </p:bgPr>
@@ -3278,8 +3253,8 @@
         </p:nvSpPr>
         <p:spPr>
           <a:xfrm>
-            <a:off x="594360" y="411480"/>
-            <a:ext cx="10972800" cy="365760"/>
+            <a:off x="731520" y="457200"/>
+            <a:ext cx="10789920" cy="365760"/>
           </a:xfrm>
           <a:prstGeom prst="rect">
             <a:avLst/>
@@ -3287,15 +3262,18 @@
           <a:noFill/>
         </p:spPr>
         <p:txBody>
-          <a:bodyPr wrap="none">
+          <a:bodyPr wrap="square">
             <a:spAutoFit/>
           </a:bodyPr>
           <a:lstStyle/>
           <a:p>
             <a:pPr>
+              <a:spcAft>
+                <a:spcPts val="2400"/>
+              </a:spcAft>
               <a:defRPr sz="1100">
                 <a:solidFill>
-                  <a:srgbClr val="176B55"/>
+                  <a:srgbClr val="FF8798"/>
                 </a:solidFill>
               </a:defRPr>
             </a:pPr>
@@ -3313,8 +3291,8 @@
         </p:nvSpPr>
         <p:spPr>
           <a:xfrm>
-            <a:off x="594360" y="1143000"/>
-            <a:ext cx="10972800" cy="1005840"/>
+            <a:off x="731520" y="1280160"/>
+            <a:ext cx="10789920" cy="1005840"/>
           </a:xfrm>
           <a:prstGeom prst="rect">
             <a:avLst/>
@@ -3322,21 +3300,23 @@
           <a:noFill/>
         </p:spPr>
         <p:txBody>
-          <a:bodyPr wrap="none">
+          <a:bodyPr wrap="square">
             <a:spAutoFit/>
           </a:bodyPr>
           <a:lstStyle/>
           <a:p>
             <a:pPr>
-              <a:defRPr sz="3700">
-                <a:solidFill>
-                  <a:srgbClr val="182D32"/>
-                </a:solidFill>
-                <a:latin typeface="Georgia"/>
+              <a:spcAft>
+                <a:spcPts val="2400"/>
+              </a:spcAft>
+              <a:defRPr sz="3600">
+                <a:solidFill>
+                  <a:srgbClr val="E8EDF1"/>
+                </a:solidFill>
               </a:defRPr>
             </a:pPr>
             <a:r>
-              <a:t>Demonstration and conclusion</a:t>
+              <a:t>Remaining evidence gaps</a:t>
             </a:r>
           </a:p>
         </p:txBody>
@@ -3349,8 +3329,8 @@
         </p:nvSpPr>
         <p:spPr>
           <a:xfrm>
-            <a:off x="685800" y="2651760"/>
-            <a:ext cx="10698480" cy="3657600"/>
+            <a:off x="731520" y="2743200"/>
+            <a:ext cx="10789920" cy="3657600"/>
           </a:xfrm>
           <a:prstGeom prst="rect">
             <a:avLst/>
@@ -3365,61 +3345,46 @@
           <a:p>
             <a:pPr>
               <a:spcAft>
-                <a:spcPts val="2200"/>
+                <a:spcPts val="2400"/>
               </a:spcAft>
-              <a:defRPr sz="2500">
-                <a:solidFill>
-                  <a:srgbClr val="344D4E"/>
+              <a:defRPr sz="2400">
+                <a:solidFill>
+                  <a:srgbClr val="A8B8C5"/>
                 </a:solidFill>
               </a:defRPr>
             </a:pPr>
             <a:r>
-              <a:t>Scout → compare → inspect dossier → solve XI</a:t>
+              <a:t>Verify complete current squads and availability</a:t>
             </a:r>
           </a:p>
           <a:p>
             <a:pPr>
               <a:spcAft>
-                <a:spcPts val="2200"/>
+                <a:spcPts val="2400"/>
               </a:spcAft>
-              <a:defRPr sz="2500">
-                <a:solidFill>
-                  <a:srgbClr val="344D4E"/>
+              <a:defRPr sz="2400">
+                <a:solidFill>
+                  <a:srgbClr val="A8B8C5"/>
                 </a:solidFill>
               </a:defRPr>
             </a:pPr>
             <a:r>
-              <a:t>Inspect forecast calibration and source evidence</a:t>
+              <a:t>Authenticate durable shared team access</a:t>
             </a:r>
           </a:p>
           <a:p>
             <a:pPr>
               <a:spcAft>
-                <a:spcPts val="2200"/>
+                <a:spcPts val="2400"/>
               </a:spcAft>
-              <a:defRPr sz="2500">
-                <a:solidFill>
-                  <a:srgbClr val="344D4E"/>
+              <a:defRPr sz="2400">
+                <a:solidFill>
+                  <a:srgbClr val="A8B8C5"/>
                 </a:solidFill>
               </a:defRPr>
             </a:pPr>
             <a:r>
-              <a:t>Save a decision and collect a real review</a:t>
-            </a:r>
-          </a:p>
-          <a:p>
-            <a:pPr>
-              <a:spcAft>
-                <a:spcPts val="2200"/>
-              </a:spcAft>
-              <a:defRPr sz="2500">
-                <a:solidFill>
-                  <a:srgbClr val="344D4E"/>
-                </a:solidFill>
-              </a:defRPr>
-            </a:pPr>
-            <a:r>
-              <a:t>Low infrastructure cost; transparent decision support</a:t>
+              <a:t>Measure expert usefulness and live provider quality</a:t>
             </a:r>
           </a:p>
         </p:txBody>
@@ -3438,7 +3403,7 @@
     <p:bg>
       <p:bgPr>
         <a:solidFill>
-          <a:srgbClr val="F6F5F0"/>
+          <a:srgbClr val="101820"/>
         </a:solidFill>
         <a:effectLst/>
       </p:bgPr>
@@ -3458,8 +3423,8 @@
         </p:nvSpPr>
         <p:spPr>
           <a:xfrm>
-            <a:off x="594360" y="411480"/>
-            <a:ext cx="10972800" cy="365760"/>
+            <a:off x="731520" y="457200"/>
+            <a:ext cx="10789920" cy="365760"/>
           </a:xfrm>
           <a:prstGeom prst="rect">
             <a:avLst/>
@@ -3467,15 +3432,18 @@
           <a:noFill/>
         </p:spPr>
         <p:txBody>
-          <a:bodyPr wrap="none">
+          <a:bodyPr wrap="square">
             <a:spAutoFit/>
           </a:bodyPr>
           <a:lstStyle/>
           <a:p>
             <a:pPr>
+              <a:spcAft>
+                <a:spcPts val="2400"/>
+              </a:spcAft>
               <a:defRPr sz="1100">
                 <a:solidFill>
-                  <a:srgbClr val="176B55"/>
+                  <a:srgbClr val="FF8798"/>
                 </a:solidFill>
               </a:defRPr>
             </a:pPr>
@@ -3493,8 +3461,8 @@
         </p:nvSpPr>
         <p:spPr>
           <a:xfrm>
-            <a:off x="594360" y="1143000"/>
-            <a:ext cx="10972800" cy="1005840"/>
+            <a:off x="731520" y="1280160"/>
+            <a:ext cx="10789920" cy="1005840"/>
           </a:xfrm>
           <a:prstGeom prst="rect">
             <a:avLst/>
@@ -3502,21 +3470,23 @@
           <a:noFill/>
         </p:spPr>
         <p:txBody>
-          <a:bodyPr wrap="none">
+          <a:bodyPr wrap="square">
             <a:spAutoFit/>
           </a:bodyPr>
           <a:lstStyle/>
           <a:p>
             <a:pPr>
-              <a:defRPr sz="3700">
-                <a:solidFill>
-                  <a:srgbClr val="182D32"/>
-                </a:solidFill>
-                <a:latin typeface="Georgia"/>
+              <a:spcAft>
+                <a:spcPts val="2400"/>
+              </a:spcAft>
+              <a:defRPr sz="3600">
+                <a:solidFill>
+                  <a:srgbClr val="E8EDF1"/>
+                </a:solidFill>
               </a:defRPr>
             </a:pPr>
             <a:r>
-              <a:t>The decision problem</a:t>
+              <a:t>The analyst workflow</a:t>
             </a:r>
           </a:p>
         </p:txBody>
@@ -3529,8 +3499,8 @@
         </p:nvSpPr>
         <p:spPr>
           <a:xfrm>
-            <a:off x="685800" y="2651760"/>
-            <a:ext cx="10698480" cy="3657600"/>
+            <a:off x="731520" y="2743200"/>
+            <a:ext cx="10789920" cy="3657600"/>
           </a:xfrm>
           <a:prstGeom prst="rect">
             <a:avLst/>
@@ -3545,61 +3515,46 @@
           <a:p>
             <a:pPr>
               <a:spcAft>
-                <a:spcPts val="2200"/>
+                <a:spcPts val="2400"/>
               </a:spcAft>
-              <a:defRPr sz="2500">
-                <a:solidFill>
-                  <a:srgbClr val="344D4E"/>
+              <a:defRPr sz="2400">
+                <a:solidFill>
+                  <a:srgbClr val="A8B8C5"/>
                 </a:solidFill>
               </a:defRPr>
             </a:pPr>
             <a:r>
-              <a:t>Find a role-fit player</a:t>
+              <a:t>Scout a role → compare evidence → confirm identity</a:t>
             </a:r>
           </a:p>
           <a:p>
             <a:pPr>
               <a:spcAft>
-                <a:spcPts val="2200"/>
+                <a:spcPts val="2400"/>
               </a:spcAft>
-              <a:defRPr sz="2500">
-                <a:solidFill>
-                  <a:srgbClr val="344D4E"/>
+              <a:defRPr sz="2400">
+                <a:solidFill>
+                  <a:srgbClr val="A8B8C5"/>
                 </a:solidFill>
               </a:defRPr>
             </a:pPr>
             <a:r>
-              <a:t>Compare evidence and uncertainty</a:t>
+              <a:t>Plan the XI and every bowling over</a:t>
             </a:r>
           </a:p>
           <a:p>
             <a:pPr>
               <a:spcAft>
-                <a:spcPts val="2200"/>
+                <a:spcPts val="2400"/>
               </a:spcAft>
-              <a:defRPr sz="2500">
-                <a:solidFill>
-                  <a:srgbClr val="344D4E"/>
+              <a:defRPr sz="2400">
+                <a:solidFill>
+                  <a:srgbClr val="A8B8C5"/>
                 </a:solidFill>
               </a:defRPr>
             </a:pPr>
             <a:r>
-              <a:t>Rebuild an XI after an exclusion</a:t>
-            </a:r>
-          </a:p>
-          <a:p>
-            <a:pPr>
-              <a:spcAft>
-                <a:spcPts val="2200"/>
-              </a:spcAft>
-              <a:defRPr sz="2500">
-                <a:solidFill>
-                  <a:srgbClr val="344D4E"/>
-                </a:solidFill>
-              </a:defRPr>
-            </a:pPr>
-            <a:r>
-              <a:t>Preserve a defensible recommendation</a:t>
+              <a:t>Inspect uncertainty → preserve the reasoning</a:t>
             </a:r>
           </a:p>
         </p:txBody>
@@ -3618,7 +3573,7 @@
     <p:bg>
       <p:bgPr>
         <a:solidFill>
-          <a:srgbClr val="F6F5F0"/>
+          <a:srgbClr val="101820"/>
         </a:solidFill>
         <a:effectLst/>
       </p:bgPr>
@@ -3638,8 +3593,8 @@
         </p:nvSpPr>
         <p:spPr>
           <a:xfrm>
-            <a:off x="594360" y="411480"/>
-            <a:ext cx="10972800" cy="365760"/>
+            <a:off x="731520" y="457200"/>
+            <a:ext cx="10789920" cy="365760"/>
           </a:xfrm>
           <a:prstGeom prst="rect">
             <a:avLst/>
@@ -3647,15 +3602,18 @@
           <a:noFill/>
         </p:spPr>
         <p:txBody>
-          <a:bodyPr wrap="none">
+          <a:bodyPr wrap="square">
             <a:spAutoFit/>
           </a:bodyPr>
           <a:lstStyle/>
           <a:p>
             <a:pPr>
+              <a:spcAft>
+                <a:spcPts val="2400"/>
+              </a:spcAft>
               <a:defRPr sz="1100">
                 <a:solidFill>
-                  <a:srgbClr val="176B55"/>
+                  <a:srgbClr val="FF8798"/>
                 </a:solidFill>
               </a:defRPr>
             </a:pPr>
@@ -3673,8 +3631,8 @@
         </p:nvSpPr>
         <p:spPr>
           <a:xfrm>
-            <a:off x="594360" y="1143000"/>
-            <a:ext cx="10972800" cy="1005840"/>
+            <a:off x="731520" y="1280160"/>
+            <a:ext cx="10789920" cy="1005840"/>
           </a:xfrm>
           <a:prstGeom prst="rect">
             <a:avLst/>
@@ -3682,21 +3640,23 @@
           <a:noFill/>
         </p:spPr>
         <p:txBody>
-          <a:bodyPr wrap="none">
+          <a:bodyPr wrap="square">
             <a:spAutoFit/>
           </a:bodyPr>
           <a:lstStyle/>
           <a:p>
             <a:pPr>
-              <a:defRPr sz="3700">
-                <a:solidFill>
-                  <a:srgbClr val="182D32"/>
-                </a:solidFill>
-                <a:latin typeface="Georgia"/>
+              <a:spcAft>
+                <a:spcPts val="2400"/>
+              </a:spcAft>
+              <a:defRPr sz="3600">
+                <a:solidFill>
+                  <a:srgbClr val="E8EDF1"/>
+                </a:solidFill>
               </a:defRPr>
             </a:pPr>
             <a:r>
-              <a:t>The evidence base</a:t>
+              <a:t>Evidence and identity</a:t>
             </a:r>
           </a:p>
         </p:txBody>
@@ -3709,8 +3669,8 @@
         </p:nvSpPr>
         <p:spPr>
           <a:xfrm>
-            <a:off x="685800" y="2651760"/>
-            <a:ext cx="10698480" cy="3657600"/>
+            <a:off x="731520" y="2743200"/>
+            <a:ext cx="10789920" cy="3657600"/>
           </a:xfrm>
           <a:prstGeom prst="rect">
             <a:avLst/>
@@ -3725,61 +3685,46 @@
           <a:p>
             <a:pPr>
               <a:spcAft>
-                <a:spcPts val="2200"/>
+                <a:spcPts val="2400"/>
               </a:spcAft>
-              <a:defRPr sz="2500">
-                <a:solidFill>
-                  <a:srgbClr val="344D4E"/>
+              <a:defRPr sz="2400">
+                <a:solidFill>
+                  <a:srgbClr val="A8B8C5"/>
                 </a:solidFill>
               </a:defRPr>
             </a:pPr>
             <a:r>
-              <a:t>6,392 eligible men’s matches</a:t>
+              <a:t>6,392 eligible men’s matches; 141,377 player-match records</a:t>
             </a:r>
           </a:p>
           <a:p>
             <a:pPr>
               <a:spcAft>
-                <a:spcPts val="2200"/>
+                <a:spcPts val="2400"/>
               </a:spcAft>
-              <a:defRPr sz="2500">
-                <a:solidFill>
-                  <a:srgbClr val="344D4E"/>
+              <a:defRPr sz="2400">
+                <a:solidFill>
+                  <a:srgbClr val="A8B8C5"/>
                 </a:solidFill>
               </a:defRPr>
             </a:pPr>
             <a:r>
-              <a:t>141,377 named player-match records</a:t>
+              <a:t>Strict dates, archive hashes and phase reconciliation</a:t>
             </a:r>
           </a:p>
           <a:p>
             <a:pPr>
               <a:spcAft>
-                <a:spcPts val="2200"/>
+                <a:spcPts val="2400"/>
               </a:spcAft>
-              <a:defRPr sz="2500">
-                <a:solidFill>
-                  <a:srgbClr val="344D4E"/>
+              <a:defRPr sz="2400">
+                <a:solidFill>
+                  <a:srgbClr val="A8B8C5"/>
                 </a:solidFill>
               </a:defRPr>
             </a:pPr>
             <a:r>
-              <a:t>IPL · BBL · SMAT · Hundred · T20I</a:t>
-            </a:r>
-          </a:p>
-          <a:p>
-            <a:pPr>
-              <a:spcAft>
-                <a:spcPts val="2200"/>
-              </a:spcAft>
-              <a:defRPr sz="2500">
-                <a:solidFill>
-                  <a:srgbClr val="344D4E"/>
-                </a:solidFill>
-              </a:defRPr>
-            </a:pPr>
-            <a:r>
-              <a:t>Source hashes and strict match-date cutoffs</a:t>
+              <a:t>Unique unregistered planning IDs; partial roster verification disclosed</a:t>
             </a:r>
           </a:p>
         </p:txBody>
@@ -3798,7 +3743,7 @@
     <p:bg>
       <p:bgPr>
         <a:solidFill>
-          <a:srgbClr val="F6F5F0"/>
+          <a:srgbClr val="101820"/>
         </a:solidFill>
         <a:effectLst/>
       </p:bgPr>
@@ -3818,8 +3763,8 @@
         </p:nvSpPr>
         <p:spPr>
           <a:xfrm>
-            <a:off x="594360" y="411480"/>
-            <a:ext cx="10972800" cy="365760"/>
+            <a:off x="731520" y="457200"/>
+            <a:ext cx="10789920" cy="365760"/>
           </a:xfrm>
           <a:prstGeom prst="rect">
             <a:avLst/>
@@ -3827,15 +3772,18 @@
           <a:noFill/>
         </p:spPr>
         <p:txBody>
-          <a:bodyPr wrap="none">
+          <a:bodyPr wrap="square">
             <a:spAutoFit/>
           </a:bodyPr>
           <a:lstStyle/>
           <a:p>
             <a:pPr>
+              <a:spcAft>
+                <a:spcPts val="2400"/>
+              </a:spcAft>
               <a:defRPr sz="1100">
                 <a:solidFill>
-                  <a:srgbClr val="176B55"/>
+                  <a:srgbClr val="FF8798"/>
                 </a:solidFill>
               </a:defRPr>
             </a:pPr>
@@ -3853,8 +3801,8 @@
         </p:nvSpPr>
         <p:spPr>
           <a:xfrm>
-            <a:off x="594360" y="1143000"/>
-            <a:ext cx="10972800" cy="1005840"/>
+            <a:off x="731520" y="1280160"/>
+            <a:ext cx="10789920" cy="1005840"/>
           </a:xfrm>
           <a:prstGeom prst="rect">
             <a:avLst/>
@@ -3862,21 +3810,23 @@
           <a:noFill/>
         </p:spPr>
         <p:txBody>
-          <a:bodyPr wrap="none">
+          <a:bodyPr wrap="square">
             <a:spAutoFit/>
           </a:bodyPr>
           <a:lstStyle/>
           <a:p>
             <a:pPr>
-              <a:defRPr sz="3700">
-                <a:solidFill>
-                  <a:srgbClr val="182D32"/>
-                </a:solidFill>
-                <a:latin typeface="Georgia"/>
+              <a:spcAft>
+                <a:spcPts val="2400"/>
+              </a:spcAft>
+              <a:defRPr sz="3600">
+                <a:solidFill>
+                  <a:srgbClr val="E8EDF1"/>
+                </a:solidFill>
               </a:defRPr>
             </a:pPr>
             <a:r>
-              <a:t>Scouting and observed uncertainty</a:t>
+              <a:t>Supported planning</a:t>
             </a:r>
           </a:p>
         </p:txBody>
@@ -3889,8 +3839,8 @@
         </p:nvSpPr>
         <p:spPr>
           <a:xfrm>
-            <a:off x="685800" y="2651760"/>
-            <a:ext cx="10698480" cy="3657600"/>
+            <a:off x="731520" y="2743200"/>
+            <a:ext cx="10789920" cy="3657600"/>
           </a:xfrm>
           <a:prstGeom prst="rect">
             <a:avLst/>
@@ -3905,61 +3855,46 @@
           <a:p>
             <a:pPr>
               <a:spcAft>
-                <a:spcPts val="2200"/>
+                <a:spcPts val="2400"/>
               </a:spcAft>
-              <a:defRPr sz="2500">
-                <a:solidFill>
-                  <a:srgbClr val="344D4E"/>
+              <a:defRPr sz="2400">
+                <a:solidFill>
+                  <a:srgbClr val="A8B8C5"/>
                 </a:solidFill>
               </a:defRPr>
             </a:pPr>
             <a:r>
-              <a:t>Pool-relative scores with 120-ball shrinkage</a:t>
+              <a:t>Exactly eleven; overseas, keeper and role constraints</a:t>
             </a:r>
           </a:p>
           <a:p>
             <a:pPr>
               <a:spcAft>
-                <a:spcPts val="2200"/>
+                <a:spcPts val="2400"/>
               </a:spcAft>
-              <a:defRPr sz="2500">
-                <a:solidFill>
-                  <a:srgbClr val="344D4E"/>
+              <a:defRPr sz="2400">
+                <a:solidFill>
+                  <a:srgbClr val="A8B8C5"/>
                 </a:solidFill>
               </a:defRPr>
             </a:pPr>
             <a:r>
-              <a:t>Phase-specific batting and bowling comparisons</a:t>
+              <a:t>36 PP / 60 middle / 24 death balls; max 24 per player</a:t>
             </a:r>
           </a:p>
           <a:p>
             <a:pPr>
               <a:spcAft>
-                <a:spcPts val="2200"/>
+                <a:spcPts val="2400"/>
               </a:spcAft>
-              <a:defRPr sz="2500">
-                <a:solidFill>
-                  <a:srgbClr val="344D4E"/>
+              <a:defRPr sz="2400">
+                <a:solidFill>
+                  <a:srgbClr val="A8B8C5"/>
                 </a:solidFill>
               </a:defRPr>
             </a:pPr>
             <a:r>
-              <a:t>Reproducible match-bootstrap intervals</a:t>
-            </a:r>
-          </a:p>
-          <a:p>
-            <a:pPr>
-              <a:spcAft>
-                <a:spcPts val="2200"/>
-              </a:spcAft>
-              <a:defRPr sz="2500">
-                <a:solidFill>
-                  <a:srgbClr val="344D4E"/>
-                </a:solidFill>
-              </a:defRPr>
-            </a:pPr>
-            <a:r>
-              <a:t>No claim of competition-strength translation</a:t>
+              <a:t>Availability, locks, styles and explicit cost assumptions</a:t>
             </a:r>
           </a:p>
         </p:txBody>
@@ -3978,7 +3913,7 @@
     <p:bg>
       <p:bgPr>
         <a:solidFill>
-          <a:srgbClr val="F6F5F0"/>
+          <a:srgbClr val="101820"/>
         </a:solidFill>
         <a:effectLst/>
       </p:bgPr>
@@ -3998,8 +3933,8 @@
         </p:nvSpPr>
         <p:spPr>
           <a:xfrm>
-            <a:off x="594360" y="411480"/>
-            <a:ext cx="10972800" cy="365760"/>
+            <a:off x="731520" y="457200"/>
+            <a:ext cx="10789920" cy="365760"/>
           </a:xfrm>
           <a:prstGeom prst="rect">
             <a:avLst/>
@@ -4007,15 +3942,18 @@
           <a:noFill/>
         </p:spPr>
         <p:txBody>
-          <a:bodyPr wrap="none">
+          <a:bodyPr wrap="square">
             <a:spAutoFit/>
           </a:bodyPr>
           <a:lstStyle/>
           <a:p>
             <a:pPr>
+              <a:spcAft>
+                <a:spcPts val="2400"/>
+              </a:spcAft>
               <a:defRPr sz="1100">
                 <a:solidFill>
-                  <a:srgbClr val="176B55"/>
+                  <a:srgbClr val="FF8798"/>
                 </a:solidFill>
               </a:defRPr>
             </a:pPr>
@@ -4033,8 +3971,8 @@
         </p:nvSpPr>
         <p:spPr>
           <a:xfrm>
-            <a:off x="594360" y="1143000"/>
-            <a:ext cx="10972800" cy="1005840"/>
+            <a:off x="731520" y="1280160"/>
+            <a:ext cx="10789920" cy="1005840"/>
           </a:xfrm>
           <a:prstGeom prst="rect">
             <a:avLst/>
@@ -4042,21 +3980,23 @@
           <a:noFill/>
         </p:spPr>
         <p:txBody>
-          <a:bodyPr wrap="none">
+          <a:bodyPr wrap="square">
             <a:spAutoFit/>
           </a:bodyPr>
           <a:lstStyle/>
           <a:p>
             <a:pPr>
-              <a:defRPr sz="3700">
-                <a:solidFill>
-                  <a:srgbClr val="182D32"/>
-                </a:solidFill>
-                <a:latin typeface="Georgia"/>
+              <a:spcAft>
+                <a:spcPts val="2400"/>
+              </a:spcAft>
+              <a:defRPr sz="3600">
+                <a:solidFill>
+                  <a:srgbClr val="E8EDF1"/>
+                </a:solidFill>
               </a:defRPr>
             </a:pPr>
             <a:r>
-              <a:t>Exact XI and budget planning</a:t>
+              <a:t>The bounded assistant</a:t>
             </a:r>
           </a:p>
         </p:txBody>
@@ -4069,8 +4009,8 @@
         </p:nvSpPr>
         <p:spPr>
           <a:xfrm>
-            <a:off x="685800" y="2651760"/>
-            <a:ext cx="10698480" cy="3657600"/>
+            <a:off x="731520" y="2743200"/>
+            <a:ext cx="10789920" cy="3657600"/>
           </a:xfrm>
           <a:prstGeom prst="rect">
             <a:avLst/>
@@ -4085,61 +4025,46 @@
           <a:p>
             <a:pPr>
               <a:spcAft>
-                <a:spcPts val="2200"/>
+                <a:spcPts val="2400"/>
               </a:spcAft>
-              <a:defRPr sz="2500">
-                <a:solidFill>
-                  <a:srgbClr val="344D4E"/>
+              <a:defRPr sz="2400">
+                <a:solidFill>
+                  <a:srgbClr val="A8B8C5"/>
                 </a:solidFill>
               </a:defRPr>
             </a:pPr>
             <a:r>
-              <a:t>11 players · overseas and role constraints</a:t>
+              <a:t>Approved tools retrieve the active scenario</a:t>
             </a:r>
           </a:p>
           <a:p>
             <a:pPr>
               <a:spcAft>
-                <a:spcPts val="2200"/>
+                <a:spcPts val="2400"/>
               </a:spcAft>
-              <a:defRPr sz="2500">
-                <a:solidFill>
-                  <a:srgbClr val="344D4E"/>
+              <a:defRPr sz="2400">
+                <a:solidFill>
+                  <a:srgbClr val="A8B8C5"/>
                 </a:solidFill>
               </a:defRPr>
             </a:pPr>
             <a:r>
-              <a:t>Locks, exclusions and full-bench scoring</a:t>
+              <a:t>Only locally rendered tool facts reach the brief</a:t>
             </a:r>
           </a:p>
           <a:p>
             <a:pPr>
               <a:spcAft>
-                <a:spcPts val="2200"/>
+                <a:spcPts val="2400"/>
               </a:spcAft>
-              <a:defRPr sz="2500">
-                <a:solidFill>
-                  <a:srgbClr val="344D4E"/>
+              <a:defRPr sz="2400">
+                <a:solidFill>
+                  <a:srgbClr val="A8B8C5"/>
                 </a:solidFill>
               </a:defRPr>
             </a:pPr>
             <a:r>
-              <a:t>Editable scenario prices and budget</a:t>
-            </a:r>
-          </a:p>
-          <a:p>
-            <a:pPr>
-              <a:spcAft>
-                <a:spcPts val="2200"/>
-              </a:spcAft>
-              <a:defRPr sz="2500">
-                <a:solidFill>
-                  <a:srgbClr val="344D4E"/>
-                </a:solidFill>
-              </a:defRPr>
-            </a:pPr>
-            <a:r>
-              <a:t>Explicit planning assumptions, not official certification</a:t>
+              <a:t>Deferred excess calls, scoped cache and outage clearing</a:t>
             </a:r>
           </a:p>
         </p:txBody>
@@ -4158,7 +4083,7 @@
     <p:bg>
       <p:bgPr>
         <a:solidFill>
-          <a:srgbClr val="F6F5F0"/>
+          <a:srgbClr val="101820"/>
         </a:solidFill>
         <a:effectLst/>
       </p:bgPr>
@@ -4178,8 +4103,8 @@
         </p:nvSpPr>
         <p:spPr>
           <a:xfrm>
-            <a:off x="594360" y="411480"/>
-            <a:ext cx="10972800" cy="365760"/>
+            <a:off x="731520" y="457200"/>
+            <a:ext cx="10789920" cy="365760"/>
           </a:xfrm>
           <a:prstGeom prst="rect">
             <a:avLst/>
@@ -4187,15 +4112,18 @@
           <a:noFill/>
         </p:spPr>
         <p:txBody>
-          <a:bodyPr wrap="none">
+          <a:bodyPr wrap="square">
             <a:spAutoFit/>
           </a:bodyPr>
           <a:lstStyle/>
           <a:p>
             <a:pPr>
+              <a:spcAft>
+                <a:spcPts val="2400"/>
+              </a:spcAft>
               <a:defRPr sz="1100">
                 <a:solidFill>
-                  <a:srgbClr val="176B55"/>
+                  <a:srgbClr val="FF8798"/>
                 </a:solidFill>
               </a:defRPr>
             </a:pPr>
@@ -4213,8 +4141,8 @@
         </p:nvSpPr>
         <p:spPr>
           <a:xfrm>
-            <a:off x="594360" y="1143000"/>
-            <a:ext cx="10972800" cy="1005840"/>
+            <a:off x="731520" y="1280160"/>
+            <a:ext cx="10789920" cy="1005840"/>
           </a:xfrm>
           <a:prstGeom prst="rect">
             <a:avLst/>
@@ -4222,21 +4150,23 @@
           <a:noFill/>
         </p:spPr>
         <p:txBody>
-          <a:bodyPr wrap="none">
+          <a:bodyPr wrap="square">
             <a:spAutoFit/>
           </a:bodyPr>
           <a:lstStyle/>
           <a:p>
             <a:pPr>
-              <a:defRPr sz="3700">
-                <a:solidFill>
-                  <a:srgbClr val="182D32"/>
-                </a:solidFill>
-                <a:latin typeface="Georgia"/>
+              <a:spcAft>
+                <a:spcPts val="2400"/>
+              </a:spcAft>
+              <a:defRPr sz="3600">
+                <a:solidFill>
+                  <a:srgbClr val="E8EDF1"/>
+                </a:solidFill>
               </a:defRPr>
             </a:pPr>
             <a:r>
-              <a:t>DeepSeek analyst</a:t>
+              <a:t>Prediction honesty</a:t>
             </a:r>
           </a:p>
         </p:txBody>
@@ -4249,8 +4179,8 @@
         </p:nvSpPr>
         <p:spPr>
           <a:xfrm>
-            <a:off x="685800" y="2651760"/>
-            <a:ext cx="10698480" cy="3657600"/>
+            <a:off x="731520" y="2743200"/>
+            <a:ext cx="10789920" cy="3657600"/>
           </a:xfrm>
           <a:prstGeom prst="rect">
             <a:avLst/>
@@ -4265,61 +4195,46 @@
           <a:p>
             <a:pPr>
               <a:spcAft>
-                <a:spcPts val="2200"/>
+                <a:spcPts val="2400"/>
               </a:spcAft>
-              <a:defRPr sz="2500">
-                <a:solidFill>
-                  <a:srgbClr val="344D4E"/>
+              <a:defRPr sz="2400">
+                <a:solidFill>
+                  <a:srgbClr val="A8B8C5"/>
                 </a:solidFill>
               </a:defRPr>
             </a:pPr>
             <a:r>
-              <a:t>Question → approved tool calls → cited brief</a:t>
+              <a:t>Training before 2023; validation 2023; test 2024 onward</a:t>
             </a:r>
           </a:p>
           <a:p>
             <a:pPr>
               <a:spcAft>
-                <a:spcPts val="2200"/>
+                <a:spcPts val="2400"/>
               </a:spcAft>
-              <a:defRPr sz="2500">
-                <a:solidFill>
-                  <a:srgbClr val="344D4E"/>
+              <a:defRPr sz="2400">
+                <a:solidFill>
+                  <a:srgbClr val="A8B8C5"/>
                 </a:solidFill>
               </a:defRPr>
             </a:pPr>
             <a:r>
-              <a:t>Numerical tools own calculations</a:t>
+              <a:t>Research model failed the stronger baseline gate</a:t>
             </a:r>
           </a:p>
           <a:p>
             <a:pPr>
               <a:spcAft>
-                <a:spcPts val="2200"/>
+                <a:spcPts val="2400"/>
               </a:spcAft>
-              <a:defRPr sz="2500">
-                <a:solidFill>
-                  <a:srgbClr val="344D4E"/>
+              <a:defRPr sz="2400">
+                <a:solidFill>
+                  <a:srgbClr val="A8B8C5"/>
                 </a:solidFill>
               </a:defRPr>
             </a:pPr>
             <a:r>
-              <a:t>Private server-side key configuration</a:t>
-            </a:r>
-          </a:p>
-          <a:p>
-            <a:pPr>
-              <a:spcAft>
-                <a:spcPts val="2200"/>
-              </a:spcAft>
-              <a:defRPr sz="2500">
-                <a:solidFill>
-                  <a:srgbClr val="344D4E"/>
-                </a:solidFill>
-              </a:defRPr>
-            </a:pPr>
-            <a:r>
-              <a:t>Bounded calls, trace, cache and journal</a:t>
+              <a:t>Serve baseline; keep model results open to scrutiny</a:t>
             </a:r>
           </a:p>
         </p:txBody>
@@ -4338,7 +4253,7 @@
     <p:bg>
       <p:bgPr>
         <a:solidFill>
-          <a:srgbClr val="F6F5F0"/>
+          <a:srgbClr val="101820"/>
         </a:solidFill>
         <a:effectLst/>
       </p:bgPr>
@@ -4358,8 +4273,8 @@
         </p:nvSpPr>
         <p:spPr>
           <a:xfrm>
-            <a:off x="594360" y="411480"/>
-            <a:ext cx="10972800" cy="365760"/>
+            <a:off x="731520" y="457200"/>
+            <a:ext cx="10789920" cy="365760"/>
           </a:xfrm>
           <a:prstGeom prst="rect">
             <a:avLst/>
@@ -4367,15 +4282,18 @@
           <a:noFill/>
         </p:spPr>
         <p:txBody>
-          <a:bodyPr wrap="none">
+          <a:bodyPr wrap="square">
             <a:spAutoFit/>
           </a:bodyPr>
           <a:lstStyle/>
           <a:p>
             <a:pPr>
+              <a:spcAft>
+                <a:spcPts val="2400"/>
+              </a:spcAft>
               <a:defRPr sz="1100">
                 <a:solidFill>
-                  <a:srgbClr val="176B55"/>
+                  <a:srgbClr val="FF8798"/>
                 </a:solidFill>
               </a:defRPr>
             </a:pPr>
@@ -4393,8 +4311,8 @@
         </p:nvSpPr>
         <p:spPr>
           <a:xfrm>
-            <a:off x="594360" y="1143000"/>
-            <a:ext cx="10972800" cy="1005840"/>
+            <a:off x="731520" y="1280160"/>
+            <a:ext cx="10789920" cy="1005840"/>
           </a:xfrm>
           <a:prstGeom prst="rect">
             <a:avLst/>
@@ -4402,21 +4320,23 @@
           <a:noFill/>
         </p:spPr>
         <p:txBody>
-          <a:bodyPr wrap="none">
+          <a:bodyPr wrap="square">
             <a:spAutoFit/>
           </a:bodyPr>
           <a:lstStyle/>
           <a:p>
             <a:pPr>
-              <a:defRPr sz="3700">
-                <a:solidFill>
-                  <a:srgbClr val="182D32"/>
-                </a:solidFill>
-                <a:latin typeface="Georgia"/>
+              <a:spcAft>
+                <a:spcPts val="2400"/>
+              </a:spcAft>
+              <a:defRPr sz="3600">
+                <a:solidFill>
+                  <a:srgbClr val="E8EDF1"/>
+                </a:solidFill>
               </a:defRPr>
             </a:pPr>
             <a:r>
-              <a:t>Prediction research</a:t>
+              <a:t>Private session records</a:t>
             </a:r>
           </a:p>
         </p:txBody>
@@ -4429,8 +4349,8 @@
         </p:nvSpPr>
         <p:spPr>
           <a:xfrm>
-            <a:off x="685800" y="2651760"/>
-            <a:ext cx="10698480" cy="3657600"/>
+            <a:off x="731520" y="2743200"/>
+            <a:ext cx="10789920" cy="3657600"/>
           </a:xfrm>
           <a:prstGeom prst="rect">
             <a:avLst/>
@@ -4445,61 +4365,46 @@
           <a:p>
             <a:pPr>
               <a:spcAft>
-                <a:spcPts val="2200"/>
+                <a:spcPts val="2400"/>
               </a:spcAft>
-              <a:defRPr sz="2500">
-                <a:solidFill>
-                  <a:srgbClr val="344D4E"/>
+              <a:defRPr sz="2400">
+                <a:solidFill>
+                  <a:srgbClr val="A8B8C5"/>
                 </a:solidFill>
               </a:defRPr>
             </a:pPr>
             <a:r>
-              <a:t>One shared evaluation and serving pipeline</a:t>
+              <a:t>Random session + franchise scope</a:t>
             </a:r>
           </a:p>
           <a:p>
             <a:pPr>
               <a:spcAft>
-                <a:spcPts val="2200"/>
+                <a:spcPts val="2400"/>
               </a:spcAft>
-              <a:defRPr sz="2500">
-                <a:solidFill>
-                  <a:srgbClr val="344D4E"/>
+              <a:defRPr sz="2400">
+                <a:solidFill>
+                  <a:srgbClr val="A8B8C5"/>
                 </a:solidFill>
               </a:defRPr>
             </a:pPr>
             <a:r>
-              <a:t>Train before 2023 · validate 2023 · test 2024–2026</a:t>
+              <a:t>No legacy shared journal reads</a:t>
             </a:r>
           </a:p>
           <a:p>
             <a:pPr>
               <a:spcAft>
-                <a:spcPts val="2200"/>
+                <a:spcPts val="2400"/>
               </a:spcAft>
-              <a:defRPr sz="2500">
-                <a:solidFill>
-                  <a:srgbClr val="344D4E"/>
+              <a:defRPr sz="2400">
+                <a:solidFill>
+                  <a:srgbClr val="A8B8C5"/>
                 </a:solidFill>
               </a:defRPr>
             </a:pPr>
             <a:r>
-              <a:t>Post-toss 54.88% accuracy on 215 matches</a:t>
-            </a:r>
-          </a:p>
-          <a:p>
-            <a:pPr>
-              <a:spcAft>
-                <a:spcPts val="2200"/>
-              </a:spcAft>
-              <a:defRPr sz="2500">
-                <a:solidFill>
-                  <a:srgbClr val="344D4E"/>
-                </a:solidFill>
-              </a:defRPr>
-            </a:pPr>
-            <a:r>
-              <a:t>95% interval 48.20–61.39%; Brier 0.248129</a:t>
+              <a:t>Export work; authenticated team accounts remain future work</a:t>
             </a:r>
           </a:p>
         </p:txBody>
@@ -4518,7 +4423,7 @@
     <p:bg>
       <p:bgPr>
         <a:solidFill>
-          <a:srgbClr val="F6F5F0"/>
+          <a:srgbClr val="101820"/>
         </a:solidFill>
         <a:effectLst/>
       </p:bgPr>
@@ -4538,8 +4443,8 @@
         </p:nvSpPr>
         <p:spPr>
           <a:xfrm>
-            <a:off x="594360" y="411480"/>
-            <a:ext cx="10972800" cy="365760"/>
+            <a:off x="731520" y="457200"/>
+            <a:ext cx="10789920" cy="365760"/>
           </a:xfrm>
           <a:prstGeom prst="rect">
             <a:avLst/>
@@ -4547,15 +4452,18 @@
           <a:noFill/>
         </p:spPr>
         <p:txBody>
-          <a:bodyPr wrap="none">
+          <a:bodyPr wrap="square">
             <a:spAutoFit/>
           </a:bodyPr>
           <a:lstStyle/>
           <a:p>
             <a:pPr>
+              <a:spcAft>
+                <a:spcPts val="2400"/>
+              </a:spcAft>
               <a:defRPr sz="1100">
                 <a:solidFill>
-                  <a:srgbClr val="176B55"/>
+                  <a:srgbClr val="FF8798"/>
                 </a:solidFill>
               </a:defRPr>
             </a:pPr>
@@ -4573,8 +4481,8 @@
         </p:nvSpPr>
         <p:spPr>
           <a:xfrm>
-            <a:off x="594360" y="1143000"/>
-            <a:ext cx="10972800" cy="1005840"/>
+            <a:off x="731520" y="1280160"/>
+            <a:ext cx="10789920" cy="1005840"/>
           </a:xfrm>
           <a:prstGeom prst="rect">
             <a:avLst/>
@@ -4582,21 +4490,23 @@
           <a:noFill/>
         </p:spPr>
         <p:txBody>
-          <a:bodyPr wrap="none">
+          <a:bodyPr wrap="square">
             <a:spAutoFit/>
           </a:bodyPr>
           <a:lstStyle/>
           <a:p>
             <a:pPr>
-              <a:defRPr sz="3700">
-                <a:solidFill>
-                  <a:srgbClr val="182D32"/>
-                </a:solidFill>
-                <a:latin typeface="Georgia"/>
+              <a:spcAft>
+                <a:spcPts val="2400"/>
+              </a:spcAft>
+              <a:defRPr sz="3600">
+                <a:solidFill>
+                  <a:srgbClr val="E8EDF1"/>
+                </a:solidFill>
               </a:defRPr>
             </a:pPr>
             <a:r>
-              <a:t>Validation and honest limits</a:t>
+              <a:t>Interface and accessibility</a:t>
             </a:r>
           </a:p>
         </p:txBody>
@@ -4609,8 +4519,8 @@
         </p:nvSpPr>
         <p:spPr>
           <a:xfrm>
-            <a:off x="685800" y="2651760"/>
-            <a:ext cx="10698480" cy="3657600"/>
+            <a:off x="731520" y="2743200"/>
+            <a:ext cx="10789920" cy="3657600"/>
           </a:xfrm>
           <a:prstGeom prst="rect">
             <a:avLst/>
@@ -4625,61 +4535,46 @@
           <a:p>
             <a:pPr>
               <a:spcAft>
-                <a:spcPts val="2200"/>
+                <a:spcPts val="2400"/>
               </a:spcAft>
-              <a:defRPr sz="2500">
-                <a:solidFill>
-                  <a:srgbClr val="344D4E"/>
+              <a:defRPr sz="2400">
+                <a:solidFill>
+                  <a:srgbClr val="A8B8C5"/>
                 </a:solidFill>
               </a:defRPr>
             </a:pPr>
             <a:r>
-              <a:t>37 offline behavioral checks passed</a:t>
+              <a:t>Ten franchise accents and bundled crests</a:t>
             </a:r>
           </a:p>
           <a:p>
             <a:pPr>
               <a:spcAft>
-                <a:spcPts val="2200"/>
+                <a:spcPts val="2400"/>
               </a:spcAft>
-              <a:defRPr sz="2500">
-                <a:solidFill>
-                  <a:srgbClr val="344D4E"/>
+              <a:defRPr sz="2400">
+                <a:solidFill>
+                  <a:srgbClr val="A8B8C5"/>
                 </a:solidFill>
               </a:defRPr>
             </a:pPr>
             <a:r>
-              <a:t>12 UI workflow checks passed</a:t>
+              <a:t>IPL vector text mark; Light and Dark modes</a:t>
             </a:r>
           </a:p>
           <a:p>
             <a:pPr>
               <a:spcAft>
-                <a:spcPts val="2200"/>
+                <a:spcPts val="2400"/>
               </a:spcAft>
-              <a:defRPr sz="2500">
-                <a:solidFill>
-                  <a:srgbClr val="344D4E"/>
+              <a:defRPr sz="2400">
+                <a:solidFill>
+                  <a:srgbClr val="A8B8C5"/>
                 </a:solidFill>
               </a:defRPr>
             </a:pPr>
             <a:r>
-              <a:t>Desktop and mobile rendering inspected</a:t>
-            </a:r>
-          </a:p>
-          <a:p>
-            <a:pPr>
-              <a:spcAft>
-                <a:spcPts val="2200"/>
-              </a:spcAft>
-              <a:defRPr sz="2500">
-                <a:solidFill>
-                  <a:srgbClr val="344D4E"/>
-                </a:solidFill>
-              </a:defRPr>
-            </a:pPr>
-            <a:r>
-              <a:t>Live AI quality and expert review remain unvalidated</a:t>
+              <a:t>Responsive typography and themed research tables</a:t>
             </a:r>
           </a:p>
         </p:txBody>
@@ -4698,7 +4593,7 @@
     <p:bg>
       <p:bgPr>
         <a:solidFill>
-          <a:srgbClr val="F6F5F0"/>
+          <a:srgbClr val="101820"/>
         </a:solidFill>
         <a:effectLst/>
       </p:bgPr>
@@ -4718,8 +4613,8 @@
         </p:nvSpPr>
         <p:spPr>
           <a:xfrm>
-            <a:off x="594360" y="411480"/>
-            <a:ext cx="10972800" cy="365760"/>
+            <a:off x="731520" y="457200"/>
+            <a:ext cx="10789920" cy="365760"/>
           </a:xfrm>
           <a:prstGeom prst="rect">
             <a:avLst/>
@@ -4727,15 +4622,18 @@
           <a:noFill/>
         </p:spPr>
         <p:txBody>
-          <a:bodyPr wrap="none">
+          <a:bodyPr wrap="square">
             <a:spAutoFit/>
           </a:bodyPr>
           <a:lstStyle/>
           <a:p>
             <a:pPr>
+              <a:spcAft>
+                <a:spcPts val="2400"/>
+              </a:spcAft>
               <a:defRPr sz="1100">
                 <a:solidFill>
-                  <a:srgbClr val="176B55"/>
+                  <a:srgbClr val="FF8798"/>
                 </a:solidFill>
               </a:defRPr>
             </a:pPr>
@@ -4753,8 +4651,8 @@
         </p:nvSpPr>
         <p:spPr>
           <a:xfrm>
-            <a:off x="594360" y="1143000"/>
-            <a:ext cx="10972800" cy="1005840"/>
+            <a:off x="731520" y="1280160"/>
+            <a:ext cx="10789920" cy="1005840"/>
           </a:xfrm>
           <a:prstGeom prst="rect">
             <a:avLst/>
@@ -4762,21 +4660,23 @@
           <a:noFill/>
         </p:spPr>
         <p:txBody>
-          <a:bodyPr wrap="none">
+          <a:bodyPr wrap="square">
             <a:spAutoFit/>
           </a:bodyPr>
           <a:lstStyle/>
           <a:p>
             <a:pPr>
-              <a:defRPr sz="3700">
-                <a:solidFill>
-                  <a:srgbClr val="182D32"/>
-                </a:solidFill>
-                <a:latin typeface="Georgia"/>
+              <a:spcAft>
+                <a:spcPts val="2400"/>
+              </a:spcAft>
+              <a:defRPr sz="3600">
+                <a:solidFill>
+                  <a:srgbClr val="E8EDF1"/>
+                </a:solidFill>
               </a:defRPr>
             </a:pPr>
             <a:r>
-              <a:t>SWOT in action</a:t>
+              <a:t>Actual validation</a:t>
             </a:r>
           </a:p>
         </p:txBody>
@@ -4789,8 +4689,8 @@
         </p:nvSpPr>
         <p:spPr>
           <a:xfrm>
-            <a:off x="685800" y="2651760"/>
-            <a:ext cx="10698480" cy="3657600"/>
+            <a:off x="731520" y="2743200"/>
+            <a:ext cx="10789920" cy="3657600"/>
           </a:xfrm>
           <a:prstGeom prst="rect">
             <a:avLst/>
@@ -4805,61 +4705,46 @@
           <a:p>
             <a:pPr>
               <a:spcAft>
-                <a:spcPts val="2200"/>
+                <a:spcPts val="2400"/>
               </a:spcAft>
-              <a:defRPr sz="2500">
-                <a:solidFill>
-                  <a:srgbClr val="344D4E"/>
+              <a:defRPr sz="2400">
+                <a:solidFill>
+                  <a:srgbClr val="A8B8C5"/>
                 </a:solidFill>
               </a:defRPr>
             </a:pPr>
             <a:r>
-              <a:t>Strength: uploaded history and exact local tools</a:t>
+              <a:t>31 core regressions</a:t>
             </a:r>
           </a:p>
           <a:p>
             <a:pPr>
               <a:spcAft>
-                <a:spcPts val="2200"/>
+                <a:spcPts val="2400"/>
               </a:spcAft>
-              <a:defRPr sz="2500">
-                <a:solidFill>
-                  <a:srgbClr val="344D4E"/>
+              <a:defRPr sz="2400">
+                <a:solidFill>
+                  <a:srgbClr val="A8B8C5"/>
                 </a:solidFill>
               </a:defRPr>
             </a:pPr>
             <a:r>
-              <a:t>Weakness: old prices and unverified availability</a:t>
+              <a:t>41 workflow checks</a:t>
             </a:r>
           </a:p>
           <a:p>
             <a:pPr>
               <a:spcAft>
-                <a:spcPts val="2200"/>
+                <a:spcPts val="2400"/>
               </a:spcAft>
-              <a:defRPr sz="2500">
-                <a:solidFill>
-                  <a:srgbClr val="344D4E"/>
+              <a:defRPr sz="2400">
+                <a:solidFill>
+                  <a:srgbClr val="A8B8C5"/>
                 </a:solidFill>
               </a:defRPr>
             </a:pPr>
             <a:r>
-              <a:t>Opportunity: traceable scouting decisions</a:t>
-            </a:r>
-          </a:p>
-          <a:p>
-            <a:pPr>
-              <a:spcAft>
-                <a:spcPts val="2200"/>
-              </a:spcAft>
-              <a:defRPr sz="2500">
-                <a:solidFill>
-                  <a:srgbClr val="344D4E"/>
-                </a:solidFill>
-              </a:defRPr>
-            </a:pPr>
-            <a:r>
-              <a:t>Threat: stale data, unsupported claims and API cost</a:t>
+              <a:t>5 local browser checks</a:t>
             </a:r>
           </a:p>
         </p:txBody>

</xml_diff>